<commit_message>
Town map picker, responsive layouts, motion, and plain-language copy
- Map of Singapore drawn from URA planning area boundaries (data.gov.sg):
  new boundaries pipeline step, bronze/gold tables, /api/map, /api/town-stats
- Town picker (map + list by region) and flat-type chips on every page;
  the chosen town's whole area is highlighted
- Responsive pass: bottom tab bar on phones, stacked tables, fixed the form
  overlapping results on one-column layouts, layouts up to 2560px
- Home page motion: headline reveal, count-up figures, scroll reveals,
  journey and data-flow sequences; respects reduced motion
- Copy rewritten in plain language with no long dashes, app and docs
- data.gov.sg rate-limit handling and optional API key; file fallback
- tests/ui_check.py: real-browser layout check at nine screen sizes
- Data refreshed to the 3 Oct 2026 snapshot; deck and docs updated

Co-Authored-By: Claude Opus 5.5 <noreply@anthropic.com>
</commit_message>
<xml_diff>
--- a/submission/FlatFair_Round1_Deck.pptx
+++ b/submission/FlatFair_Round1_Deck.pptx
@@ -3714,7 +3714,7 @@
                 </a:solidFill>
                 <a:latin typeface="Arial"/>
               </a:rPr>
-              <a:t>Problem statement (e.g. A2 — Ageing in place): </a:t>
+              <a:t>Problem statement: </a:t>
             </a:r>
             <a:r>
               <a:rPr sz="1300" b="1">
@@ -3723,7 +3723,7 @@
                 </a:solidFill>
                 <a:latin typeface="Arial"/>
               </a:rPr>
-              <a:t>C1 — FlatFair: HDB resale market intelligence &amp; affordability forecasting</a:t>
+              <a:t>C1 FlatFair: HDB resale market intelligence &amp; affordability forecasting</a:t>
             </a:r>
           </a:p>
           <a:p>
@@ -3758,7 +3758,7 @@
                 </a:solidFill>
                 <a:latin typeface="Arial"/>
               </a:rPr>
-              <a:t>Young Singaporeans are making the biggest purchase of their lives in a market where HDB resale prices rose </a:t>
+              <a:t>HDB resale prices rose </a:t>
             </a:r>
             <a:r>
               <a:rPr sz="1300" b="1">
@@ -3794,7 +3794,7 @@
                 </a:solidFill>
                 <a:latin typeface="Arial"/>
               </a:rPr>
-              <a:t>, with no transparent way to judge whether an asking price, or the repayment behind it, is reasonable.</a:t>
+              <a:t>. First-time buyers have no simple way to tell if an asking price, or the repayment that comes with it, is reasonable.</a:t>
             </a:r>
           </a:p>
           <a:p>
@@ -3829,7 +3829,7 @@
                 </a:solidFill>
                 <a:latin typeface="Arial"/>
               </a:rPr>
-              <a:t>24,662 households</a:t>
+              <a:t>24,661 households</a:t>
             </a:r>
             <a:r>
               <a:rPr sz="1300" b="0">
@@ -3838,7 +3838,7 @@
                 </a:solidFill>
                 <a:latin typeface="Arial"/>
               </a:rPr>
-              <a:t> bought a resale flat in the last 12 months; </a:t>
+              <a:t> bought a resale flat in the last 12 months. </a:t>
             </a:r>
             <a:r>
               <a:rPr sz="1300" b="1">
@@ -3874,7 +3874,7 @@
                 </a:solidFill>
                 <a:latin typeface="Arial"/>
               </a:rPr>
-              <a:t> of the median household’s income, up from 3.8 in 2017.</a:t>
+              <a:t> of the median household’s income, up from 3.8 years in 2017.</a:t>
             </a:r>
           </a:p>
           <a:p>
@@ -3909,7 +3909,7 @@
                 </a:solidFill>
                 <a:latin typeface="Arial"/>
               </a:rPr>
-              <a:t>After a 50% climb since 2020, prices have flattened (</a:t>
+              <a:t>Prices climbed 50% from 2020 and have now levelled off (</a:t>
             </a:r>
             <a:r>
               <a:rPr sz="1300" b="1">
@@ -3918,7 +3918,7 @@
                 </a:solidFill>
                 <a:latin typeface="Arial"/>
               </a:rPr>
-              <a:t>+1.3% year on year</a:t>
+              <a:t>+1.3% in the past year</a:t>
             </a:r>
             <a:r>
               <a:rPr sz="1300" b="0">
@@ -3927,7 +3927,7 @@
                 </a:solidFill>
                 <a:latin typeface="Arial"/>
               </a:rPr>
-              <a:t>), so rising values no longer cover an overpayment. Since August 2024 an HDB loan needs a </a:t>
+              <a:t>). A rising market no longer makes up for overpaying. Since August 2024 an HDB loan also needs a </a:t>
             </a:r>
             <a:r>
               <a:rPr sz="1300" b="1">
@@ -3945,7 +3945,7 @@
                 </a:solidFill>
                 <a:latin typeface="Arial"/>
               </a:rPr>
-              <a:t> instead of 20%, and the October 2024 Standard, Plus and Prime framework has reset expectations again.</a:t>
+              <a:t>, up from 20%.</a:t>
             </a:r>
           </a:p>
         </p:txBody>
@@ -4278,7 +4278,7 @@
                 </a:solidFill>
                 <a:latin typeface="Arial"/>
               </a:rPr>
-              <a:t>FlatFair turns HDB’s resale records into a five-step decision tool that takes a buyer from </a:t>
+              <a:t>FlatFair takes a buyer from </a:t>
             </a:r>
             <a:r>
               <a:rPr sz="1300" b="1">
@@ -4305,7 +4305,16 @@
                 </a:solidFill>
                 <a:latin typeface="Arial"/>
               </a:rPr>
-              <a:t>“is this flat, at this price, sensible for us?”</a:t>
+              <a:t>“is this flat, at this price, right for us?”</a:t>
+            </a:r>
+            <a:r>
+              <a:rPr sz="1300" b="0">
+                <a:solidFill>
+                  <a:srgbClr val="112530"/>
+                </a:solidFill>
+                <a:latin typeface="Arial"/>
+              </a:rPr>
+              <a:t> in five steps, using HDB’s own resale records.</a:t>
             </a:r>
           </a:p>
           <a:p>
@@ -4340,7 +4349,7 @@
                 </a:solidFill>
                 <a:latin typeface="Arial"/>
               </a:rPr>
-              <a:t>First-time resale buyers, and the counsellors and planners who advise them. It changes </a:t>
+              <a:t>First-time resale buyers, and the housing counsellors and planners who advise them. It helps them decide </a:t>
             </a:r>
             <a:r>
               <a:rPr sz="1300" b="1">
@@ -4349,7 +4358,7 @@
                 </a:solidFill>
                 <a:latin typeface="Arial"/>
               </a:rPr>
-              <a:t>where they look</a:t>
+              <a:t>where to look</a:t>
             </a:r>
             <a:r>
               <a:rPr sz="1300" b="0">
@@ -4358,7 +4367,7 @@
                 </a:solidFill>
                 <a:latin typeface="Arial"/>
               </a:rPr>
-              <a:t> (towns ranked by what the household can repay), </a:t>
+              <a:t> (towns that fit their budget), </a:t>
             </a:r>
             <a:r>
               <a:rPr sz="1300" b="1">
@@ -4367,7 +4376,7 @@
                 </a:solidFill>
                 <a:latin typeface="Arial"/>
               </a:rPr>
-              <a:t>what they offer</a:t>
+              <a:t>what to offer</a:t>
             </a:r>
             <a:r>
               <a:rPr sz="1300" b="0">
@@ -4376,7 +4385,7 @@
                 </a:solidFill>
                 <a:latin typeface="Arial"/>
               </a:rPr>
-              <a:t> (asking price vs estimated value and the 5 closest sales) and </a:t>
+              <a:t> (asking price against the estimate and the 5 closest sales) and </a:t>
             </a:r>
             <a:r>
               <a:rPr sz="1300" b="1">
@@ -4385,7 +4394,7 @@
                 </a:solidFill>
                 <a:latin typeface="Arial"/>
               </a:rPr>
-              <a:t>when they buy</a:t>
+              <a:t>when to buy</a:t>
             </a:r>
             <a:r>
               <a:rPr sz="1300" b="0">
@@ -4394,7 +4403,7 @@
                 </a:solidFill>
                 <a:latin typeface="Arial"/>
               </a:rPr>
-              <a:t> (a tested six-month outlook).</a:t>
+              <a:t> (a six-month forecast).</a:t>
             </a:r>
           </a:p>
           <a:p>
@@ -4447,7 +4456,7 @@
                 </a:solidFill>
                 <a:latin typeface="Arial"/>
               </a:rPr>
-              <a:t> — data.gov.sg d_8b84c4ee…6abc, 241,822 sales</a:t>
+              <a:t>, data.gov.sg (d_8b84c4ee…6abc), 241,920 sales</a:t>
             </a:r>
           </a:p>
           <a:p>
@@ -4481,7 +4490,7 @@
                 </a:solidFill>
                 <a:latin typeface="Arial"/>
               </a:rPr>
-              <a:t> — SingStat Table Builder</a:t>
+              <a:t>, SingStat Table Builder</a:t>
             </a:r>
           </a:p>
           <a:p>
@@ -4506,7 +4515,7 @@
                 </a:solidFill>
                 <a:latin typeface="Arial"/>
               </a:rPr>
-              <a:t>HDB Annual Report 2025 · Population by Planning Area</a:t>
+              <a:t>Master Plan 2019 Planning Area Boundary</a:t>
             </a:r>
             <a:r>
               <a:rPr sz="1200" b="0">
@@ -4515,7 +4524,7 @@
                 </a:solidFill>
                 <a:latin typeface="Arial"/>
               </a:rPr>
-              <a:t> — HDB, SingStat (supply and demand context)</a:t>
+              <a:t>, URA via data.gov.sg (town map). Plus HDB Annual Report 2025 for supply context</a:t>
             </a:r>
           </a:p>
           <a:p>
@@ -4550,7 +4559,7 @@
                 </a:solidFill>
                 <a:latin typeface="Arial"/>
               </a:rPr>
-              <a:t>It values a specific flat, not just the market: an 80% price range tested on </a:t>
+              <a:t>It prices one specific flat and shows the monthly repayment against the 30% limit. The price model was tested on </a:t>
             </a:r>
             <a:r>
               <a:rPr sz="1300" b="1">
@@ -4559,7 +4568,7 @@
                 </a:solidFill>
                 <a:latin typeface="Arial"/>
               </a:rPr>
-              <a:t>13,589 sales it never saw</a:t>
+              <a:t>13,588 sales it had never seen</a:t>
             </a:r>
             <a:r>
               <a:rPr sz="1300" b="0">
@@ -4568,7 +4577,7 @@
                 </a:solidFill>
                 <a:latin typeface="Arial"/>
               </a:rPr>
-              <a:t> (median error </a:t>
+              <a:t>: typical miss </a:t>
             </a:r>
             <a:r>
               <a:rPr sz="1300" b="1">
@@ -4586,7 +4595,7 @@
                 </a:solidFill>
                 <a:latin typeface="Arial"/>
               </a:rPr>
-              <a:t> vs 9.5% for the $/sqm rule of thumb), plus repayment against the 30% MSR cap. Every model must beat a simple baseline: when a 3-month average out-forecast our ML model, we published the average.</a:t>
+              <a:t>, against 9.5% for the price-per-sqm rule of thumb. Every model has to beat a simple baseline. A 3-month average forecast better than our ML model, so we use the average.</a:t>
             </a:r>
           </a:p>
         </p:txBody>
@@ -4608,7 +4617,7 @@
         <p:spPr>
           <a:xfrm>
             <a:off x="7726679" y="1783080"/>
-            <a:ext cx="3639312" cy="3657600"/>
+            <a:ext cx="3760499" cy="3657600"/>
           </a:xfrm>
           <a:prstGeom prst="rect">
             <a:avLst/>
@@ -4658,7 +4667,7 @@
                 </a:solidFill>
                 <a:latin typeface="Arial"/>
               </a:rPr>
-              <a:t>a Tampines 4-room asking $690,000 sits within the expected $612k–$710k range. flatfair-nine.vercel.app</a:t>
+              <a:t>a Tampines 4-room asking $690,000 sits within the usual $615k to $713k range. flatfair-nine.vercel.app</a:t>
             </a:r>
           </a:p>
         </p:txBody>
@@ -5636,7 +5645,7 @@
                 </a:solidFill>
                 <a:latin typeface="Arial"/>
               </a:rPr>
-              <a:t>market explorer, six-month forecast with its range, affordability with “Where can I afford?”, fair value with comparable sales, and town comparison. </a:t>
+              <a:t>pick a town on a map of Singapore, then see its market, a six-month forecast, what you can afford, a fair price with comparable sales, and other towns side by side. </a:t>
             </a:r>
             <a:r>
               <a:rPr sz="1300" b="1">
@@ -5703,7 +5712,7 @@
                 </a:solidFill>
                 <a:latin typeface="Arial"/>
               </a:rPr>
-              <a:t>On a typical $630k flat the pricing blind spot narrows from </a:t>
+              <a:t>On a typical $630k flat, the usual pricing miss drops from </a:t>
             </a:r>
             <a:r>
               <a:rPr sz="1300" b="1">
@@ -5712,7 +5721,7 @@
                 </a:solidFill>
                 <a:latin typeface="Arial"/>
               </a:rPr>
-              <a:t>~$60k to ~$25k</a:t>
+              <a:t>about $60k to about $25k</a:t>
             </a:r>
             <a:r>
               <a:rPr sz="1300" b="0">
@@ -5721,7 +5730,7 @@
                 </a:solidFill>
                 <a:latin typeface="Arial"/>
               </a:rPr>
-              <a:t> (rule-of-thumb vs model median error). Every buyer sees repayment against the 30% MSR cap before committing, refreshed monthly from open data.</a:t>
+              <a:t>. Buyers see the repayment against the 30% limit before they commit. The data refreshes every month.</a:t>
             </a:r>
           </a:p>
         </p:txBody>
@@ -5779,7 +5788,7 @@
                 </a:solidFill>
                 <a:latin typeface="Arial"/>
               </a:rPr>
-              <a:t>Pipeline, both models, the app and 66 tests are built. </a:t>
+              <a:t>Pipeline, both models, the app and 77 tests are built. </a:t>
             </a:r>
             <a:r>
               <a:rPr sz="1300" b="0">
@@ -5788,7 +5797,7 @@
                 </a:solidFill>
                 <a:latin typeface="Arial"/>
               </a:rPr>
-              <a:t>Sprint: run it as a Lakeflow Job in the final workspace, deploy on Databricks Apps, add a Genie space and dashboard, test with five first-time buyers.</a:t>
+              <a:t>In the sprint: run it as a Lakeflow Job in the final workspace, deploy on Databricks Apps, add a Genie space and dashboard, and test with five first-time buyers.</a:t>
             </a:r>
           </a:p>
         </p:txBody>

</xml_diff>